<commit_message>
Shorten presentation to 7 key slides
Co-Authored-By: Devin AI <158243242+devin-ai-integration[bot]@users.noreply.github.com>
</commit_message>
<xml_diff>
--- a/PROJECT_PRESENTATION.pptx
+++ b/PROJECT_PRESENTATION.pptx
@@ -13,10 +13,6 @@
     <p:sldId id="261" r:id="rId12"/>
     <p:sldId id="262" r:id="rId13"/>
     <p:sldId id="263" r:id="rId14"/>
-    <p:sldId id="264" r:id="rId15"/>
-    <p:sldId id="265" r:id="rId16"/>
-    <p:sldId id="266" r:id="rId17"/>
-    <p:sldId id="267" r:id="rId18"/>
   </p:sldIdLst>
   <p:sldSz cx="12191695" cy="6858000" type="screen4x3"/>
   <p:notesSz cx="6858000" cy="9144000"/>
@@ -3136,291 +3132,7 @@
           <a:lstStyle/>
           <a:p>
             <a:r>
-              <a:t>Project Presentation</a:t>
-            </a:r>
-          </a:p>
-        </p:txBody>
-      </p:sp>
-    </p:spTree>
-  </p:cSld>
-  <p:clrMapOvr>
-    <a:masterClrMapping/>
-  </p:clrMapOvr>
-</p:sld>
-</file>
-
-<file path=ppt/slides/slide10.xml><?xml version="1.0" encoding="utf-8"?>
-<p:sld xmlns:a="http://schemas.openxmlformats.org/drawingml/2006/main" xmlns:p="http://schemas.openxmlformats.org/presentationml/2006/main" xmlns:r="http://schemas.openxmlformats.org/officeDocument/2006/relationships">
-  <p:cSld>
-    <p:spTree>
-      <p:nvGrpSpPr>
-        <p:cNvPr id="1" name=""/>
-        <p:cNvGrpSpPr/>
-        <p:nvPr/>
-      </p:nvGrpSpPr>
-      <p:grpSpPr/>
-      <p:sp>
-        <p:nvSpPr>
-          <p:cNvPr id="2" name="Title 1"/>
-          <p:cNvSpPr>
-            <a:spLocks noGrp="1"/>
-          </p:cNvSpPr>
-          <p:nvPr>
-            <p:ph type="title"/>
-          </p:nvPr>
-        </p:nvSpPr>
-        <p:spPr/>
-        <p:txBody>
-          <a:bodyPr/>
-          <a:lstStyle/>
-          <a:p>
-            <a:r>
-              <a:t>Testing &amp; Deployment</a:t>
-            </a:r>
-          </a:p>
-        </p:txBody>
-      </p:sp>
-      <p:sp>
-        <p:nvSpPr>
-          <p:cNvPr id="3" name="Content Placeholder 2"/>
-          <p:cNvSpPr>
-            <a:spLocks noGrp="1"/>
-          </p:cNvSpPr>
-          <p:nvPr>
-            <p:ph idx="1"/>
-          </p:nvPr>
-        </p:nvSpPr>
-        <p:spPr/>
-        <p:txBody>
-          <a:bodyPr/>
-          <a:lstStyle/>
-          <a:p>
-            <a:r>
-              <a:t>Unit tests in tests/test_student_support_chatbot.py</a:t>
-            </a:r>
-          </a:p>
-          <a:p>
-            <a:pPr>
-              <a:defRPr sz="2000"/>
-            </a:pPr>
-            <a:r>
-              <a:t>Run tests with: python -m unittest</a:t>
-            </a:r>
-          </a:p>
-          <a:p>
-            <a:pPr>
-              <a:defRPr sz="2000"/>
-            </a:pPr>
-            <a:r>
-              <a:t>Local deployment:</a:t>
-            </a:r>
-          </a:p>
-          <a:p>
-            <a:pPr>
-              <a:defRPr sz="2000"/>
-            </a:pPr>
-            <a:r>
-              <a:t>   pip install -r requirements.txt</a:t>
-            </a:r>
-          </a:p>
-          <a:p>
-            <a:pPr>
-              <a:defRPr sz="2000"/>
-            </a:pPr>
-            <a:r>
-              <a:t>   (optional) python train_model.py</a:t>
-            </a:r>
-          </a:p>
-          <a:p>
-            <a:pPr>
-              <a:defRPr sz="2000"/>
-            </a:pPr>
-            <a:r>
-              <a:t>   python app.py</a:t>
-            </a:r>
-          </a:p>
-          <a:p>
-            <a:pPr>
-              <a:defRPr sz="2000"/>
-            </a:pPr>
-            <a:r>
-              <a:t>   Open http://localhost:5000</a:t>
-            </a:r>
-          </a:p>
-        </p:txBody>
-      </p:sp>
-    </p:spTree>
-  </p:cSld>
-  <p:clrMapOvr>
-    <a:masterClrMapping/>
-  </p:clrMapOvr>
-</p:sld>
-</file>
-
-<file path=ppt/slides/slide11.xml><?xml version="1.0" encoding="utf-8"?>
-<p:sld xmlns:a="http://schemas.openxmlformats.org/drawingml/2006/main" xmlns:p="http://schemas.openxmlformats.org/presentationml/2006/main" xmlns:r="http://schemas.openxmlformats.org/officeDocument/2006/relationships">
-  <p:cSld>
-    <p:spTree>
-      <p:nvGrpSpPr>
-        <p:cNvPr id="1" name=""/>
-        <p:cNvGrpSpPr/>
-        <p:nvPr/>
-      </p:nvGrpSpPr>
-      <p:grpSpPr/>
-      <p:sp>
-        <p:nvSpPr>
-          <p:cNvPr id="2" name="Title 1"/>
-          <p:cNvSpPr>
-            <a:spLocks noGrp="1"/>
-          </p:cNvSpPr>
-          <p:nvPr>
-            <p:ph type="title"/>
-          </p:nvPr>
-        </p:nvSpPr>
-        <p:spPr/>
-        <p:txBody>
-          <a:bodyPr/>
-          <a:lstStyle/>
-          <a:p>
-            <a:r>
-              <a:t>Advantages &amp; Future Scope</a:t>
-            </a:r>
-          </a:p>
-        </p:txBody>
-      </p:sp>
-      <p:sp>
-        <p:nvSpPr>
-          <p:cNvPr id="3" name="Content Placeholder 2"/>
-          <p:cNvSpPr>
-            <a:spLocks noGrp="1"/>
-          </p:cNvSpPr>
-          <p:nvPr>
-            <p:ph idx="1"/>
-          </p:nvPr>
-        </p:nvSpPr>
-        <p:spPr/>
-        <p:txBody>
-          <a:bodyPr/>
-          <a:lstStyle/>
-          <a:p>
-            <a:r>
-              <a:t>Easy to understand, extend, and deploy</a:t>
-            </a:r>
-          </a:p>
-          <a:p>
-            <a:pPr>
-              <a:defRPr sz="2000"/>
-            </a:pPr>
-            <a:r>
-              <a:t>No external API needed for basic operation</a:t>
-            </a:r>
-          </a:p>
-          <a:p>
-            <a:pPr>
-              <a:defRPr sz="2000"/>
-            </a:pPr>
-            <a:r>
-              <a:t>ML model can be retrained with new FAQs</a:t>
-            </a:r>
-          </a:p>
-          <a:p>
-            <a:pPr>
-              <a:defRPr sz="2000"/>
-            </a:pPr>
-            <a:r>
-              <a:t>Future: expand topics, add conversation history</a:t>
-            </a:r>
-          </a:p>
-          <a:p>
-            <a:pPr>
-              <a:defRPr sz="2000"/>
-            </a:pPr>
-            <a:r>
-              <a:t>Future: database storage, voice input, multi-language, cloud deploy</a:t>
-            </a:r>
-          </a:p>
-        </p:txBody>
-      </p:sp>
-    </p:spTree>
-  </p:cSld>
-  <p:clrMapOvr>
-    <a:masterClrMapping/>
-  </p:clrMapOvr>
-</p:sld>
-</file>
-
-<file path=ppt/slides/slide12.xml><?xml version="1.0" encoding="utf-8"?>
-<p:sld xmlns:a="http://schemas.openxmlformats.org/drawingml/2006/main" xmlns:p="http://schemas.openxmlformats.org/presentationml/2006/main" xmlns:r="http://schemas.openxmlformats.org/officeDocument/2006/relationships">
-  <p:cSld>
-    <p:spTree>
-      <p:nvGrpSpPr>
-        <p:cNvPr id="1" name=""/>
-        <p:cNvGrpSpPr/>
-        <p:nvPr/>
-      </p:nvGrpSpPr>
-      <p:grpSpPr/>
-      <p:sp>
-        <p:nvSpPr>
-          <p:cNvPr id="2" name="Title 1"/>
-          <p:cNvSpPr>
-            <a:spLocks noGrp="1"/>
-          </p:cNvSpPr>
-          <p:nvPr>
-            <p:ph type="title"/>
-          </p:nvPr>
-        </p:nvSpPr>
-        <p:spPr/>
-        <p:txBody>
-          <a:bodyPr/>
-          <a:lstStyle/>
-          <a:p>
-            <a:r>
-              <a:t>Conclusion</a:t>
-            </a:r>
-          </a:p>
-        </p:txBody>
-      </p:sp>
-      <p:sp>
-        <p:nvSpPr>
-          <p:cNvPr id="3" name="Content Placeholder 2"/>
-          <p:cNvSpPr>
-            <a:spLocks noGrp="1"/>
-          </p:cNvSpPr>
-          <p:nvPr>
-            <p:ph idx="1"/>
-          </p:nvPr>
-        </p:nvSpPr>
-        <p:spPr/>
-        <p:txBody>
-          <a:bodyPr/>
-          <a:lstStyle/>
-          <a:p>
-            <a:r>
-              <a:t>A practical hybrid chatbot for student support</a:t>
-            </a:r>
-          </a:p>
-          <a:p>
-            <a:pPr>
-              <a:defRPr sz="2000"/>
-            </a:pPr>
-            <a:r>
-              <a:t>Built with simple, modern Python web and ML tools</a:t>
-            </a:r>
-          </a:p>
-          <a:p>
-            <a:pPr>
-              <a:defRPr sz="2000"/>
-            </a:pPr>
-            <a:r>
-              <a:t>Ready for local testing and future scaling</a:t>
-            </a:r>
-          </a:p>
-          <a:p>
-            <a:pPr>
-              <a:defRPr sz="2000"/>
-            </a:pPr>
-            <a:r>
-              <a:t>Provides a strong base for a full student support assistant</a:t>
+              <a:t>Short Project Presentation</a:t>
             </a:r>
           </a:p>
         </p:txBody>
@@ -3459,7 +3171,7 @@
           <a:lstStyle/>
           <a:p>
             <a:r>
-              <a:t>Introduction</a:t>
+              <a:t>What is it?</a:t>
             </a:r>
           </a:p>
         </p:txBody>
@@ -3480,28 +3192,20 @@
           <a:lstStyle/>
           <a:p>
             <a:r>
-              <a:t>AI-powered conversational assistant for student queries</a:t>
+              <a:t>An AI chatbot for common student queries</a:t>
             </a:r>
           </a:p>
           <a:p>
             <a:pPr>
-              <a:defRPr sz="2000"/>
+              <a:defRPr sz="2200"/>
             </a:pPr>
             <a:r>
-              <a:t>Answers FAQs on admissions, registration, support hours, etc.</a:t>
+              <a:t>Handles admissions, registration, support hours, and general FAQs</a:t>
             </a:r>
           </a:p>
           <a:p>
             <a:pPr>
-              <a:defRPr sz="2000"/>
-            </a:pPr>
-            <a:r>
-              <a:t>Combines rule-based patterns, ML classification, and optional Gemini fallback</a:t>
-            </a:r>
-          </a:p>
-          <a:p>
-            <a:pPr>
-              <a:defRPr sz="2000"/>
+              <a:defRPr sz="2200"/>
             </a:pPr>
             <a:r>
               <a:t>Built with Python, Flask, scikit-learn, and a simple web UI</a:t>
@@ -3543,7 +3247,7 @@
           <a:lstStyle/>
           <a:p>
             <a:r>
-              <a:t>Objectives</a:t>
+              <a:t>Why build it?</a:t>
             </a:r>
           </a:p>
         </p:txBody>
@@ -3564,39 +3268,23 @@
           <a:lstStyle/>
           <a:p>
             <a:r>
-              <a:t>Provide 24/7 automated student support</a:t>
+              <a:t>Provide 24/7 instant student support</a:t>
             </a:r>
           </a:p>
           <a:p>
             <a:pPr>
-              <a:defRPr sz="2000"/>
+              <a:defRPr sz="2200"/>
             </a:pPr>
             <a:r>
-              <a:t>Reduce workload on human support staff</a:t>
+              <a:t>Reduce repetitive questions for staff</a:t>
             </a:r>
           </a:p>
           <a:p>
             <a:pPr>
-              <a:defRPr sz="2000"/>
+              <a:defRPr sz="2200"/>
             </a:pPr>
             <a:r>
-              <a:t>Deliver fast, consistent responses</a:t>
-            </a:r>
-          </a:p>
-          <a:p>
-            <a:pPr>
-              <a:defRPr sz="2000"/>
-            </a:pPr>
-            <a:r>
-              <a:t>Offer a lightweight, responsive web interface</a:t>
-            </a:r>
-          </a:p>
-          <a:p>
-            <a:pPr>
-              <a:defRPr sz="2000"/>
-            </a:pPr>
-            <a:r>
-              <a:t>Demonstrate a clean fallback strategy for unknown questions</a:t>
+              <a:t>Fast, consistent responses with a lightweight design</a:t>
             </a:r>
           </a:p>
         </p:txBody>
@@ -3635,7 +3323,7 @@
           <a:lstStyle/>
           <a:p>
             <a:r>
-              <a:t>Scope</a:t>
+              <a:t>How it works</a:t>
             </a:r>
           </a:p>
         </p:txBody>
@@ -3656,39 +3344,47 @@
           <a:lstStyle/>
           <a:p>
             <a:r>
-              <a:t>Web chat interface for student questions</a:t>
+              <a:t>User types a message in the web chat</a:t>
             </a:r>
           </a:p>
           <a:p>
             <a:pPr>
-              <a:defRPr sz="2000"/>
+              <a:defRPr sz="2200"/>
             </a:pPr>
             <a:r>
-              <a:t>Flask REST API to process messages</a:t>
+              <a:t>Flask API sends it to StudentSupportChatbot</a:t>
             </a:r>
           </a:p>
           <a:p>
             <a:pPr>
-              <a:defRPr sz="2000"/>
+              <a:defRPr sz="2200"/>
             </a:pPr>
             <a:r>
-              <a:t>Hybrid response engine: rules + ML + generative AI</a:t>
+              <a:t>Three-tier response:</a:t>
             </a:r>
           </a:p>
           <a:p>
             <a:pPr>
-              <a:defRPr sz="2000"/>
+              <a:defRPr sz="2200"/>
             </a:pPr>
             <a:r>
-              <a:t>Model training pipeline with scikit-learn</a:t>
+              <a:t>  1. ML classifier predicts the intent</a:t>
             </a:r>
           </a:p>
           <a:p>
             <a:pPr>
-              <a:defRPr sz="2000"/>
+              <a:defRPr sz="2200"/>
             </a:pPr>
             <a:r>
-              <a:t>Unit tests for core response behaviors</a:t>
+              <a:t>  2. Regex rule patterns match common FAQs</a:t>
+            </a:r>
+          </a:p>
+          <a:p>
+            <a:pPr>
+              <a:defRPr sz="2200"/>
+            </a:pPr>
+            <a:r>
+              <a:t>  3. Optional Gemini API fallback for unknown questions</a:t>
             </a:r>
           </a:p>
         </p:txBody>
@@ -3727,7 +3423,7 @@
           <a:lstStyle/>
           <a:p>
             <a:r>
-              <a:t>Technology Stack</a:t>
+              <a:t>Tech Stack</a:t>
             </a:r>
           </a:p>
         </p:txBody>
@@ -3748,55 +3444,39 @@
           <a:lstStyle/>
           <a:p>
             <a:r>
-              <a:t>Frontend: HTML5, CSS3, JavaScript</a:t>
+              <a:t>Backend: Python + Flask</a:t>
             </a:r>
           </a:p>
           <a:p>
             <a:pPr>
-              <a:defRPr sz="2000"/>
+              <a:defRPr sz="2200"/>
             </a:pPr>
             <a:r>
-              <a:t>Backend: Python + Flask</a:t>
+              <a:t>ML: scikit-learn (TF-IDF + Logistic Regression), joblib</a:t>
             </a:r>
           </a:p>
           <a:p>
             <a:pPr>
-              <a:defRPr sz="2000"/>
+              <a:defRPr sz="2200"/>
             </a:pPr>
             <a:r>
-              <a:t>Machine Learning: scikit-learn, joblib</a:t>
+              <a:t>Frontend: HTML, CSS, JavaScript</a:t>
             </a:r>
           </a:p>
           <a:p>
             <a:pPr>
-              <a:defRPr sz="2000"/>
+              <a:defRPr sz="2200"/>
             </a:pPr>
             <a:r>
-              <a:t>External AI: Google Gemini API (optional)</a:t>
+              <a:t>External API: Google Gemini (optional)</a:t>
             </a:r>
           </a:p>
           <a:p>
             <a:pPr>
-              <a:defRPr sz="2000"/>
+              <a:defRPr sz="2200"/>
             </a:pPr>
             <a:r>
-              <a:t>HTTP client: requests</a:t>
-            </a:r>
-          </a:p>
-          <a:p>
-            <a:pPr>
-              <a:defRPr sz="2000"/>
-            </a:pPr>
-            <a:r>
               <a:t>Testing: Python unittest</a:t>
-            </a:r>
-          </a:p>
-          <a:p>
-            <a:pPr>
-              <a:defRPr sz="2000"/>
-            </a:pPr>
-            <a:r>
-              <a:t>Version Control: Git &amp; GitHub</a:t>
             </a:r>
           </a:p>
         </p:txBody>
@@ -3835,7 +3515,7 @@
           <a:lstStyle/>
           <a:p>
             <a:r>
-              <a:t>System Architecture</a:t>
+              <a:t>Key Features</a:t>
             </a:r>
           </a:p>
         </p:txBody>
@@ -3856,55 +3536,31 @@
           <a:lstStyle/>
           <a:p>
             <a:r>
-              <a:t>Browser sends POST request to /api/chat</a:t>
+              <a:t>Hybrid ML + rule + generative response engine</a:t>
             </a:r>
           </a:p>
           <a:p>
             <a:pPr>
-              <a:defRPr sz="2000"/>
+              <a:defRPr sz="2200"/>
             </a:pPr>
             <a:r>
-              <a:t>Flask app invokes StudentSupportChatbot.respond()</a:t>
+              <a:t>Responsive single-page web chat UI</a:t>
             </a:r>
           </a:p>
           <a:p>
             <a:pPr>
-              <a:defRPr sz="2000"/>
+              <a:defRPr sz="2200"/>
             </a:pPr>
             <a:r>
-              <a:t>Response order:</a:t>
+              <a:t>Offline fallback with no API key needed</a:t>
             </a:r>
           </a:p>
           <a:p>
             <a:pPr>
-              <a:defRPr sz="2000"/>
+              <a:defRPr sz="2200"/>
             </a:pPr>
             <a:r>
-              <a:t>   1. ML classifier predicts label</a:t>
-            </a:r>
-          </a:p>
-          <a:p>
-            <a:pPr>
-              <a:defRPr sz="2000"/>
-            </a:pPr>
-            <a:r>
-              <a:t>   2. Rule-based regex patterns</a:t>
-            </a:r>
-          </a:p>
-          <a:p>
-            <a:pPr>
-              <a:defRPr sz="2000"/>
-            </a:pPr>
-            <a:r>
-              <a:t>   3. Gemini API fallback (if API key set)</a:t>
-            </a:r>
-          </a:p>
-          <a:p>
-            <a:pPr>
-              <a:defRPr sz="2000"/>
-            </a:pPr>
-            <a:r>
-              <a:t>   4. Default support-team message</a:t>
+              <a:t>Easy to retrain and extend with new FAQ data</a:t>
             </a:r>
           </a:p>
         </p:txBody>
@@ -3943,7 +3599,7 @@
           <a:lstStyle/>
           <a:p>
             <a:r>
-              <a:t>Core Modules</a:t>
+              <a:t>Deployment</a:t>
             </a:r>
           </a:p>
         </p:txBody>
@@ -3964,39 +3620,39 @@
           <a:lstStyle/>
           <a:p>
             <a:r>
-              <a:t>Chatbot Engine: pattern rules, ML inference, Gemini fallback</a:t>
+              <a:t>Install dependencies: pip install -r requirements.txt</a:t>
             </a:r>
           </a:p>
           <a:p>
             <a:pPr>
-              <a:defRPr sz="2000"/>
+              <a:defRPr sz="2200"/>
             </a:pPr>
             <a:r>
-              <a:t>Training Pipeline: TfidfVectorizer + LogisticRegression</a:t>
+              <a:t>Train model (optional): python train_model.py</a:t>
             </a:r>
           </a:p>
           <a:p>
             <a:pPr>
-              <a:defRPr sz="2000"/>
+              <a:defRPr sz="2200"/>
             </a:pPr>
             <a:r>
-              <a:t>Flask Web App: static frontend + /api/chat endpoint</a:t>
+              <a:t>Run server: python app.py</a:t>
             </a:r>
           </a:p>
           <a:p>
             <a:pPr>
-              <a:defRPr sz="2000"/>
+              <a:defRPr sz="2200"/>
             </a:pPr>
             <a:r>
-              <a:t>Frontend UI: chat card, composer, typing indicator</a:t>
+              <a:t>Open: http://localhost:5000</a:t>
             </a:r>
           </a:p>
           <a:p>
             <a:pPr>
-              <a:defRPr sz="2000"/>
+              <a:defRPr sz="2200"/>
             </a:pPr>
             <a:r>
-              <a:t>Tests: unittest coverage for greetings, hours, registration, unknown</a:t>
+              <a:t>Set GEMINI_API_KEY for generative fallback</a:t>
             </a:r>
           </a:p>
         </p:txBody>
@@ -4035,7 +3691,7 @@
           <a:lstStyle/>
           <a:p>
             <a:r>
-              <a:t>Key Features</a:t>
+              <a:t>Future Scope</a:t>
             </a:r>
           </a:p>
         </p:txBody>
@@ -4056,139 +3712,31 @@
           <a:lstStyle/>
           <a:p>
             <a:r>
-              <a:t>Hybrid response engine (ML + rules + generative AI)</a:t>
+              <a:t>Expand FAQ dataset and topics</a:t>
             </a:r>
           </a:p>
           <a:p>
             <a:pPr>
-              <a:defRPr sz="2000"/>
+              <a:defRPr sz="2200"/>
             </a:pPr>
             <a:r>
-              <a:t>Lightweight Flask backend</a:t>
+              <a:t>Add conversation history and database storage</a:t>
             </a:r>
           </a:p>
           <a:p>
             <a:pPr>
-              <a:defRPr sz="2000"/>
+              <a:defRPr sz="2200"/>
             </a:pPr>
             <a:r>
-              <a:t>Responsive single-page chat UI</a:t>
+              <a:t>Multi-language support and voice input</a:t>
             </a:r>
           </a:p>
           <a:p>
             <a:pPr>
-              <a:defRPr sz="2000"/>
+              <a:defRPr sz="2200"/>
             </a:pPr>
             <a:r>
-              <a:t>Command-line chat mode for testing</a:t>
-            </a:r>
-          </a:p>
-          <a:p>
-            <a:pPr>
-              <a:defRPr sz="2000"/>
-            </a:pPr>
-            <a:r>
-              <a:t>Offline fallback when no API key is configured</a:t>
-            </a:r>
-          </a:p>
-          <a:p>
-            <a:pPr>
-              <a:defRPr sz="2000"/>
-            </a:pPr>
-            <a:r>
-              <a:t>Secure API key handling via environment variables</a:t>
-            </a:r>
-          </a:p>
-        </p:txBody>
-      </p:sp>
-    </p:spTree>
-  </p:cSld>
-  <p:clrMapOvr>
-    <a:masterClrMapping/>
-  </p:clrMapOvr>
-</p:sld>
-</file>
-
-<file path=ppt/slides/slide9.xml><?xml version="1.0" encoding="utf-8"?>
-<p:sld xmlns:a="http://schemas.openxmlformats.org/drawingml/2006/main" xmlns:p="http://schemas.openxmlformats.org/presentationml/2006/main" xmlns:r="http://schemas.openxmlformats.org/officeDocument/2006/relationships">
-  <p:cSld>
-    <p:spTree>
-      <p:nvGrpSpPr>
-        <p:cNvPr id="1" name=""/>
-        <p:cNvGrpSpPr/>
-        <p:nvPr/>
-      </p:nvGrpSpPr>
-      <p:grpSpPr/>
-      <p:sp>
-        <p:nvSpPr>
-          <p:cNvPr id="2" name="Title 1"/>
-          <p:cNvSpPr>
-            <a:spLocks noGrp="1"/>
-          </p:cNvSpPr>
-          <p:nvPr>
-            <p:ph type="title"/>
-          </p:nvPr>
-        </p:nvSpPr>
-        <p:spPr/>
-        <p:txBody>
-          <a:bodyPr/>
-          <a:lstStyle/>
-          <a:p>
-            <a:r>
-              <a:t>Use Cases</a:t>
-            </a:r>
-          </a:p>
-        </p:txBody>
-      </p:sp>
-      <p:sp>
-        <p:nvSpPr>
-          <p:cNvPr id="3" name="Content Placeholder 2"/>
-          <p:cNvSpPr>
-            <a:spLocks noGrp="1"/>
-          </p:cNvSpPr>
-          <p:nvPr>
-            <p:ph idx="1"/>
-          </p:nvPr>
-        </p:nvSpPr>
-        <p:spPr/>
-        <p:txBody>
-          <a:bodyPr/>
-          <a:lstStyle/>
-          <a:p>
-            <a:r>
-              <a:t>Student greets the bot and receives a welcome message</a:t>
-            </a:r>
-          </a:p>
-          <a:p>
-            <a:pPr>
-              <a:defRPr sz="2000"/>
-            </a:pPr>
-            <a:r>
-              <a:t>Student asks support hours and gets the schedule</a:t>
-            </a:r>
-          </a:p>
-          <a:p>
-            <a:pPr>
-              <a:defRPr sz="2000"/>
-            </a:pPr>
-            <a:r>
-              <a:t>Student asks about registration and is directed to the portal</a:t>
-            </a:r>
-          </a:p>
-          <a:p>
-            <a:pPr>
-              <a:defRPr sz="2000"/>
-            </a:pPr>
-            <a:r>
-              <a:t>Unrecognized questions trigger Gemini or a support-team fallback</a:t>
-            </a:r>
-          </a:p>
-          <a:p>
-            <a:pPr>
-              <a:defRPr sz="2000"/>
-            </a:pPr>
-            <a:r>
-              <a:t>Helps reduce repetitive queries to human staff</a:t>
+              <a:t>Deploy to cloud for public access</a:t>
             </a:r>
           </a:p>
         </p:txBody>

</xml_diff>

<commit_message>
Add frontend screenshots to project presentation
Co-Authored-By: Devin AI <158243242+devin-ai-integration[bot]@users.noreply.github.com>
</commit_message>
<xml_diff>
--- a/PROJECT_PRESENTATION.pptx
+++ b/PROJECT_PRESENTATION.pptx
@@ -12,7 +12,6 @@
     <p:sldId id="260" r:id="rId11"/>
     <p:sldId id="261" r:id="rId12"/>
     <p:sldId id="262" r:id="rId13"/>
-    <p:sldId id="263" r:id="rId14"/>
   </p:sldIdLst>
   <p:sldSz cx="12191695" cy="6858000" type="screen4x3"/>
   <p:notesSz cx="6858000" cy="9144000"/>
@@ -3132,7 +3131,7 @@
           <a:lstStyle/>
           <a:p>
             <a:r>
-              <a:t>Short Project Presentation</a:t>
+              <a:t>Project Presentation with Frontend Views</a:t>
             </a:r>
           </a:p>
         </p:txBody>
@@ -3208,7 +3207,7 @@
               <a:defRPr sz="2200"/>
             </a:pPr>
             <a:r>
-              <a:t>Built with Python, Flask, scikit-learn, and a simple web UI</a:t>
+              <a:t>Built with Python, Flask, scikit-learn, and a responsive web UI</a:t>
             </a:r>
           </a:p>
         </p:txBody>
@@ -3233,62 +3232,84 @@
       <p:grpSpPr/>
       <p:sp>
         <p:nvSpPr>
-          <p:cNvPr id="2" name="Title 1"/>
-          <p:cNvSpPr>
-            <a:spLocks noGrp="1"/>
-          </p:cNvSpPr>
-          <p:nvPr>
-            <p:ph type="title"/>
-          </p:nvPr>
-        </p:nvSpPr>
-        <p:spPr/>
-        <p:txBody>
-          <a:bodyPr/>
-          <a:lstStyle/>
-          <a:p>
-            <a:r>
-              <a:t>Why build it?</a:t>
-            </a:r>
-          </a:p>
-        </p:txBody>
-      </p:sp>
-      <p:sp>
-        <p:nvSpPr>
-          <p:cNvPr id="3" name="Content Placeholder 2"/>
-          <p:cNvSpPr>
-            <a:spLocks noGrp="1"/>
-          </p:cNvSpPr>
-          <p:nvPr>
-            <p:ph idx="1"/>
-          </p:nvPr>
-        </p:nvSpPr>
-        <p:spPr/>
-        <p:txBody>
-          <a:bodyPr/>
-          <a:lstStyle/>
-          <a:p>
-            <a:r>
-              <a:t>Provide 24/7 instant student support</a:t>
-            </a:r>
-          </a:p>
+          <p:cNvPr id="2" name="TextBox 1"/>
+          <p:cNvSpPr txBox="1"/>
+          <p:nvPr/>
+        </p:nvSpPr>
+        <p:spPr>
+          <a:xfrm>
+            <a:off x="457200" y="274320"/>
+            <a:ext cx="10972800" cy="731520"/>
+          </a:xfrm>
+          <a:prstGeom prst="rect">
+            <a:avLst/>
+          </a:prstGeom>
+          <a:noFill/>
+        </p:spPr>
+        <p:txBody>
+          <a:bodyPr wrap="none">
+            <a:spAutoFit/>
+          </a:bodyPr>
+          <a:lstStyle/>
+          <a:p>
+            <a:r>
+              <a:t>Frontend: Initial Chat View</a:t>
+            </a:r>
+          </a:p>
+        </p:txBody>
+      </p:sp>
+      <p:sp>
+        <p:nvSpPr>
+          <p:cNvPr id="3" name="TextBox 2"/>
+          <p:cNvSpPr txBox="1"/>
+          <p:nvPr/>
+        </p:nvSpPr>
+        <p:spPr>
+          <a:xfrm>
+            <a:off x="457200" y="274320"/>
+            <a:ext cx="10972800" cy="731520"/>
+          </a:xfrm>
+          <a:prstGeom prst="rect">
+            <a:avLst/>
+          </a:prstGeom>
+          <a:noFill/>
+        </p:spPr>
+        <p:txBody>
+          <a:bodyPr wrap="none">
+            <a:spAutoFit/>
+          </a:bodyPr>
+          <a:lstStyle/>
           <a:p>
             <a:pPr>
-              <a:defRPr sz="2200"/>
+              <a:defRPr sz="2800"/>
             </a:pPr>
-            <a:r>
-              <a:t>Reduce repetitive questions for staff</a:t>
-            </a:r>
-          </a:p>
-          <a:p>
-            <a:pPr>
-              <a:defRPr sz="2200"/>
-            </a:pPr>
-            <a:r>
-              <a:t>Fast, consistent responses with a lightweight design</a:t>
-            </a:r>
-          </a:p>
-        </p:txBody>
-      </p:sp>
+          </a:p>
+        </p:txBody>
+      </p:sp>
+      <p:pic>
+        <p:nvPicPr>
+          <p:cNvPr id="4" name="Picture 3" descr="ss_11369aaf.png"/>
+          <p:cNvPicPr>
+            <a:picLocks noChangeAspect="1"/>
+          </p:cNvPicPr>
+          <p:nvPr/>
+        </p:nvPicPr>
+        <p:blipFill>
+          <a:blip r:embed="rId2"/>
+          <a:stretch>
+            <a:fillRect/>
+          </a:stretch>
+        </p:blipFill>
+        <p:spPr>
+          <a:xfrm>
+            <a:off x="1371600" y="1097280"/>
+            <a:ext cx="9418320" cy="7063740"/>
+          </a:xfrm>
+          <a:prstGeom prst="rect">
+            <a:avLst/>
+          </a:prstGeom>
+        </p:spPr>
+      </p:pic>
     </p:spTree>
   </p:cSld>
   <p:clrMapOvr>
@@ -3309,86 +3330,59 @@
       <p:grpSpPr/>
       <p:sp>
         <p:nvSpPr>
-          <p:cNvPr id="2" name="Title 1"/>
-          <p:cNvSpPr>
-            <a:spLocks noGrp="1"/>
-          </p:cNvSpPr>
-          <p:nvPr>
-            <p:ph type="title"/>
-          </p:nvPr>
-        </p:nvSpPr>
-        <p:spPr/>
-        <p:txBody>
-          <a:bodyPr/>
-          <a:lstStyle/>
-          <a:p>
-            <a:r>
-              <a:t>How it works</a:t>
-            </a:r>
-          </a:p>
-        </p:txBody>
-      </p:sp>
-      <p:sp>
-        <p:nvSpPr>
-          <p:cNvPr id="3" name="Content Placeholder 2"/>
-          <p:cNvSpPr>
-            <a:spLocks noGrp="1"/>
-          </p:cNvSpPr>
-          <p:nvPr>
-            <p:ph idx="1"/>
-          </p:nvPr>
-        </p:nvSpPr>
-        <p:spPr/>
-        <p:txBody>
-          <a:bodyPr/>
-          <a:lstStyle/>
-          <a:p>
-            <a:r>
-              <a:t>User types a message in the web chat</a:t>
-            </a:r>
-          </a:p>
+          <p:cNvPr id="2" name="TextBox 1"/>
+          <p:cNvSpPr txBox="1"/>
+          <p:nvPr/>
+        </p:nvSpPr>
+        <p:spPr>
+          <a:xfrm>
+            <a:off x="457200" y="274320"/>
+            <a:ext cx="10972800" cy="731520"/>
+          </a:xfrm>
+          <a:prstGeom prst="rect">
+            <a:avLst/>
+          </a:prstGeom>
+          <a:noFill/>
+        </p:spPr>
+        <p:txBody>
+          <a:bodyPr wrap="none">
+            <a:spAutoFit/>
+          </a:bodyPr>
+          <a:lstStyle/>
           <a:p>
             <a:pPr>
-              <a:defRPr sz="2200"/>
+              <a:defRPr sz="2800"/>
             </a:pPr>
             <a:r>
-              <a:t>Flask API sends it to StudentSupportChatbot</a:t>
-            </a:r>
-          </a:p>
-          <a:p>
-            <a:pPr>
-              <a:defRPr sz="2200"/>
-            </a:pPr>
-            <a:r>
-              <a:t>Three-tier response:</a:t>
-            </a:r>
-          </a:p>
-          <a:p>
-            <a:pPr>
-              <a:defRPr sz="2200"/>
-            </a:pPr>
-            <a:r>
-              <a:t>  1. ML classifier predicts the intent</a:t>
-            </a:r>
-          </a:p>
-          <a:p>
-            <a:pPr>
-              <a:defRPr sz="2200"/>
-            </a:pPr>
-            <a:r>
-              <a:t>  2. Regex rule patterns match common FAQs</a:t>
-            </a:r>
-          </a:p>
-          <a:p>
-            <a:pPr>
-              <a:defRPr sz="2200"/>
-            </a:pPr>
-            <a:r>
-              <a:t>  3. Optional Gemini API fallback for unknown questions</a:t>
-            </a:r>
-          </a:p>
-        </p:txBody>
-      </p:sp>
+              <a:t>Conversation Demo</a:t>
+            </a:r>
+          </a:p>
+        </p:txBody>
+      </p:sp>
+      <p:pic>
+        <p:nvPicPr>
+          <p:cNvPr id="3" name="Picture 2" descr="ss_56b7107a.png"/>
+          <p:cNvPicPr>
+            <a:picLocks noChangeAspect="1"/>
+          </p:cNvPicPr>
+          <p:nvPr/>
+        </p:nvPicPr>
+        <p:blipFill>
+          <a:blip r:embed="rId2"/>
+          <a:stretch>
+            <a:fillRect/>
+          </a:stretch>
+        </p:blipFill>
+        <p:spPr>
+          <a:xfrm>
+            <a:off x="1371600" y="1097280"/>
+            <a:ext cx="9418320" cy="7063740"/>
+          </a:xfrm>
+          <a:prstGeom prst="rect">
+            <a:avLst/>
+          </a:prstGeom>
+        </p:spPr>
+      </p:pic>
     </p:spTree>
   </p:cSld>
   <p:clrMapOvr>
@@ -3468,7 +3462,7 @@
               <a:defRPr sz="2200"/>
             </a:pPr>
             <a:r>
-              <a:t>External API: Google Gemini (optional)</a:t>
+              <a:t>External AI: Google Gemini API (optional)</a:t>
             </a:r>
           </a:p>
           <a:p>
@@ -3515,7 +3509,7 @@
           <a:lstStyle/>
           <a:p>
             <a:r>
-              <a:t>Key Features</a:t>
+              <a:t>How it works</a:t>
             </a:r>
           </a:p>
         </p:txBody>
@@ -3536,7 +3530,7 @@
           <a:lstStyle/>
           <a:p>
             <a:r>
-              <a:t>Hybrid ML + rule + generative response engine</a:t>
+              <a:t>Browser sends message to Flask API</a:t>
             </a:r>
           </a:p>
           <a:p>
@@ -3544,7 +3538,7 @@
               <a:defRPr sz="2200"/>
             </a:pPr>
             <a:r>
-              <a:t>Responsive single-page web chat UI</a:t>
+              <a:t>Response order:</a:t>
             </a:r>
           </a:p>
           <a:p>
@@ -3552,7 +3546,7 @@
               <a:defRPr sz="2200"/>
             </a:pPr>
             <a:r>
-              <a:t>Offline fallback with no API key needed</a:t>
+              <a:t>   1. ML classifier predicts the intent</a:t>
             </a:r>
           </a:p>
           <a:p>
@@ -3560,7 +3554,15 @@
               <a:defRPr sz="2200"/>
             </a:pPr>
             <a:r>
-              <a:t>Easy to retrain and extend with new FAQ data</a:t>
+              <a:t>   2. Regex rule patterns match common FAQs</a:t>
+            </a:r>
+          </a:p>
+          <a:p>
+            <a:pPr>
+              <a:defRPr sz="2200"/>
+            </a:pPr>
+            <a:r>
+              <a:t>   3. Optional Gemini API fallback</a:t>
             </a:r>
           </a:p>
         </p:txBody>
@@ -3599,7 +3601,7 @@
           <a:lstStyle/>
           <a:p>
             <a:r>
-              <a:t>Deployment</a:t>
+              <a:t>Deployment &amp; Future</a:t>
             </a:r>
           </a:p>
         </p:txBody>
@@ -3620,7 +3622,7 @@
           <a:lstStyle/>
           <a:p>
             <a:r>
-              <a:t>Install dependencies: pip install -r requirements.txt</a:t>
+              <a:t>Run: pip install -r requirements.txt &amp;&amp; python app.py</a:t>
             </a:r>
           </a:p>
           <a:p>
@@ -3628,7 +3630,7 @@
               <a:defRPr sz="2200"/>
             </a:pPr>
             <a:r>
-              <a:t>Train model (optional): python train_model.py</a:t>
+              <a:t>Open http://localhost:5000</a:t>
             </a:r>
           </a:p>
           <a:p>
@@ -3636,107 +3638,7 @@
               <a:defRPr sz="2200"/>
             </a:pPr>
             <a:r>
-              <a:t>Run server: python app.py</a:t>
-            </a:r>
-          </a:p>
-          <a:p>
-            <a:pPr>
-              <a:defRPr sz="2200"/>
-            </a:pPr>
-            <a:r>
-              <a:t>Open: http://localhost:5000</a:t>
-            </a:r>
-          </a:p>
-          <a:p>
-            <a:pPr>
-              <a:defRPr sz="2200"/>
-            </a:pPr>
-            <a:r>
-              <a:t>Set GEMINI_API_KEY for generative fallback</a:t>
-            </a:r>
-          </a:p>
-        </p:txBody>
-      </p:sp>
-    </p:spTree>
-  </p:cSld>
-  <p:clrMapOvr>
-    <a:masterClrMapping/>
-  </p:clrMapOvr>
-</p:sld>
-</file>
-
-<file path=ppt/slides/slide8.xml><?xml version="1.0" encoding="utf-8"?>
-<p:sld xmlns:a="http://schemas.openxmlformats.org/drawingml/2006/main" xmlns:p="http://schemas.openxmlformats.org/presentationml/2006/main" xmlns:r="http://schemas.openxmlformats.org/officeDocument/2006/relationships">
-  <p:cSld>
-    <p:spTree>
-      <p:nvGrpSpPr>
-        <p:cNvPr id="1" name=""/>
-        <p:cNvGrpSpPr/>
-        <p:nvPr/>
-      </p:nvGrpSpPr>
-      <p:grpSpPr/>
-      <p:sp>
-        <p:nvSpPr>
-          <p:cNvPr id="2" name="Title 1"/>
-          <p:cNvSpPr>
-            <a:spLocks noGrp="1"/>
-          </p:cNvSpPr>
-          <p:nvPr>
-            <p:ph type="title"/>
-          </p:nvPr>
-        </p:nvSpPr>
-        <p:spPr/>
-        <p:txBody>
-          <a:bodyPr/>
-          <a:lstStyle/>
-          <a:p>
-            <a:r>
-              <a:t>Future Scope</a:t>
-            </a:r>
-          </a:p>
-        </p:txBody>
-      </p:sp>
-      <p:sp>
-        <p:nvSpPr>
-          <p:cNvPr id="3" name="Content Placeholder 2"/>
-          <p:cNvSpPr>
-            <a:spLocks noGrp="1"/>
-          </p:cNvSpPr>
-          <p:nvPr>
-            <p:ph idx="1"/>
-          </p:nvPr>
-        </p:nvSpPr>
-        <p:spPr/>
-        <p:txBody>
-          <a:bodyPr/>
-          <a:lstStyle/>
-          <a:p>
-            <a:r>
-              <a:t>Expand FAQ dataset and topics</a:t>
-            </a:r>
-          </a:p>
-          <a:p>
-            <a:pPr>
-              <a:defRPr sz="2200"/>
-            </a:pPr>
-            <a:r>
-              <a:t>Add conversation history and database storage</a:t>
-            </a:r>
-          </a:p>
-          <a:p>
-            <a:pPr>
-              <a:defRPr sz="2200"/>
-            </a:pPr>
-            <a:r>
-              <a:t>Multi-language support and voice input</a:t>
-            </a:r>
-          </a:p>
-          <a:p>
-            <a:pPr>
-              <a:defRPr sz="2200"/>
-            </a:pPr>
-            <a:r>
-              <a:t>Deploy to cloud for public access</a:t>
+              <a:t>Future: expand FAQs, add history/database, multi-language, cloud deploy</a:t>
             </a:r>
           </a:p>
         </p:txBody>

</xml_diff>